<commit_message>
Reconcile evaluator scores, update Figure 7, add OSF preregistration DOI, and update compiled PDFs
</commit_message>
<xml_diff>
--- a/BCHAIN-ACCESS_Package/BCHAIN-ACCESS_All_Figures.pptx
+++ b/BCHAIN-ACCESS_Package/BCHAIN-ACCESS_All_Figures.pptx
@@ -5,15 +5,15 @@
     <p:sldMasterId id="2147483648" r:id="rId1"/>
   </p:sldMasterIdLst>
   <p:sldIdLst>
-    <p:sldId id="256" r:id="rId7"/>
-    <p:sldId id="257" r:id="rId8"/>
-    <p:sldId id="258" r:id="rId9"/>
-    <p:sldId id="259" r:id="rId10"/>
-    <p:sldId id="260" r:id="rId11"/>
-    <p:sldId id="261" r:id="rId12"/>
-    <p:sldId id="262" r:id="rId13"/>
+    <p:sldId id="256" r:id="rId2"/>
+    <p:sldId id="257" r:id="rId3"/>
+    <p:sldId id="258" r:id="rId4"/>
+    <p:sldId id="259" r:id="rId5"/>
+    <p:sldId id="260" r:id="rId6"/>
+    <p:sldId id="261" r:id="rId7"/>
+    <p:sldId id="262" r:id="rId8"/>
   </p:sldIdLst>
-  <p:sldSz cx="12191695" cy="6858000" type="screen4x3"/>
+  <p:sldSz cx="12192000" cy="6858000"/>
   <p:notesSz cx="6858000" cy="9144000"/>
   <p:defaultTextStyle>
     <a:defPPr>
@@ -110,6 +110,22 @@
       </a:defRPr>
     </a:lvl9pPr>
   </p:defaultTextStyle>
+  <p:extLst>
+    <p:ext uri="{EFAFB233-063F-42B5-8137-9DF3F51BA10A}">
+      <p15:sldGuideLst xmlns:p15="http://schemas.microsoft.com/office/powerpoint/2012/main">
+        <p15:guide id="1" orient="horz" pos="2160">
+          <p15:clr>
+            <a:srgbClr val="A4A3A4"/>
+          </p15:clr>
+        </p15:guide>
+        <p15:guide id="2" pos="2880">
+          <p15:clr>
+            <a:srgbClr val="A4A3A4"/>
+          </p15:clr>
+        </p15:guide>
+      </p15:sldGuideLst>
+    </p:ext>
+  </p:extLst>
 </p:presentation>
 </file>
 
@@ -151,10 +167,9 @@
           <a:lstStyle/>
           <a:p>
             <a:r>
-              <a:rPr lang="en-US" smtClean="0"/>
+              <a:rPr lang="en-US"/>
               <a:t>Click to edit Master title style</a:t>
             </a:r>
-            <a:endParaRPr lang="en-US"/>
           </a:p>
         </p:txBody>
       </p:sp>
@@ -270,10 +285,9 @@
           </a:lstStyle>
           <a:p>
             <a:r>
-              <a:rPr lang="en-US" smtClean="0"/>
+              <a:rPr lang="en-US"/>
               <a:t>Click to edit Master subtitle style</a:t>
             </a:r>
-            <a:endParaRPr lang="en-US"/>
           </a:p>
         </p:txBody>
       </p:sp>
@@ -294,7 +308,7 @@
           <a:p>
             <a:fld id="{5BCAD085-E8A6-8845-BD4E-CB4CCA059FC4}" type="datetimeFigureOut">
               <a:rPr lang="en-US" smtClean="0"/>
-              <a:t>1/27/13</a:t>
+              <a:t>7/10/2026</a:t>
             </a:fld>
             <a:endParaRPr lang="en-US"/>
           </a:p>
@@ -388,10 +402,9 @@
           <a:lstStyle/>
           <a:p>
             <a:r>
-              <a:rPr lang="en-US" smtClean="0"/>
+              <a:rPr lang="en-US"/>
               <a:t>Click to edit Master title style</a:t>
             </a:r>
-            <a:endParaRPr lang="en-US"/>
           </a:p>
         </p:txBody>
       </p:sp>
@@ -412,38 +425,37 @@
           <a:p>
             <a:pPr lvl="0"/>
             <a:r>
-              <a:rPr lang="en-US" smtClean="0"/>
+              <a:rPr lang="en-US"/>
               <a:t>Click to edit Master text styles</a:t>
             </a:r>
           </a:p>
           <a:p>
             <a:pPr lvl="1"/>
             <a:r>
-              <a:rPr lang="en-US" smtClean="0"/>
+              <a:rPr lang="en-US"/>
               <a:t>Second level</a:t>
             </a:r>
           </a:p>
           <a:p>
             <a:pPr lvl="2"/>
             <a:r>
-              <a:rPr lang="en-US" smtClean="0"/>
+              <a:rPr lang="en-US"/>
               <a:t>Third level</a:t>
             </a:r>
           </a:p>
           <a:p>
             <a:pPr lvl="3"/>
             <a:r>
-              <a:rPr lang="en-US" smtClean="0"/>
+              <a:rPr lang="en-US"/>
               <a:t>Fourth level</a:t>
             </a:r>
           </a:p>
           <a:p>
             <a:pPr lvl="4"/>
             <a:r>
-              <a:rPr lang="en-US" smtClean="0"/>
+              <a:rPr lang="en-US"/>
               <a:t>Fifth level</a:t>
             </a:r>
-            <a:endParaRPr lang="en-US"/>
           </a:p>
         </p:txBody>
       </p:sp>
@@ -464,7 +476,7 @@
           <a:p>
             <a:fld id="{5BCAD085-E8A6-8845-BD4E-CB4CCA059FC4}" type="datetimeFigureOut">
               <a:rPr lang="en-US" smtClean="0"/>
-              <a:t>1/27/13</a:t>
+              <a:t>7/10/2026</a:t>
             </a:fld>
             <a:endParaRPr lang="en-US"/>
           </a:p>
@@ -563,10 +575,9 @@
           <a:lstStyle/>
           <a:p>
             <a:r>
-              <a:rPr lang="en-US" smtClean="0"/>
+              <a:rPr lang="en-US"/>
               <a:t>Click to edit Master title style</a:t>
             </a:r>
-            <a:endParaRPr lang="en-US"/>
           </a:p>
         </p:txBody>
       </p:sp>
@@ -592,38 +603,37 @@
           <a:p>
             <a:pPr lvl="0"/>
             <a:r>
-              <a:rPr lang="en-US" smtClean="0"/>
+              <a:rPr lang="en-US"/>
               <a:t>Click to edit Master text styles</a:t>
             </a:r>
           </a:p>
           <a:p>
             <a:pPr lvl="1"/>
             <a:r>
-              <a:rPr lang="en-US" smtClean="0"/>
+              <a:rPr lang="en-US"/>
               <a:t>Second level</a:t>
             </a:r>
           </a:p>
           <a:p>
             <a:pPr lvl="2"/>
             <a:r>
-              <a:rPr lang="en-US" smtClean="0"/>
+              <a:rPr lang="en-US"/>
               <a:t>Third level</a:t>
             </a:r>
           </a:p>
           <a:p>
             <a:pPr lvl="3"/>
             <a:r>
-              <a:rPr lang="en-US" smtClean="0"/>
+              <a:rPr lang="en-US"/>
               <a:t>Fourth level</a:t>
             </a:r>
           </a:p>
           <a:p>
             <a:pPr lvl="4"/>
             <a:r>
-              <a:rPr lang="en-US" smtClean="0"/>
+              <a:rPr lang="en-US"/>
               <a:t>Fifth level</a:t>
             </a:r>
-            <a:endParaRPr lang="en-US"/>
           </a:p>
         </p:txBody>
       </p:sp>
@@ -644,7 +654,7 @@
           <a:p>
             <a:fld id="{5BCAD085-E8A6-8845-BD4E-CB4CCA059FC4}" type="datetimeFigureOut">
               <a:rPr lang="en-US" smtClean="0"/>
-              <a:t>1/27/13</a:t>
+              <a:t>7/10/2026</a:t>
             </a:fld>
             <a:endParaRPr lang="en-US"/>
           </a:p>
@@ -738,10 +748,9 @@
           <a:lstStyle/>
           <a:p>
             <a:r>
-              <a:rPr lang="en-US" smtClean="0"/>
+              <a:rPr lang="en-US"/>
               <a:t>Click to edit Master title style</a:t>
             </a:r>
-            <a:endParaRPr lang="en-US"/>
           </a:p>
         </p:txBody>
       </p:sp>
@@ -762,38 +771,37 @@
           <a:p>
             <a:pPr lvl="0"/>
             <a:r>
-              <a:rPr lang="en-US" smtClean="0"/>
+              <a:rPr lang="en-US"/>
               <a:t>Click to edit Master text styles</a:t>
             </a:r>
           </a:p>
           <a:p>
             <a:pPr lvl="1"/>
             <a:r>
-              <a:rPr lang="en-US" smtClean="0"/>
+              <a:rPr lang="en-US"/>
               <a:t>Second level</a:t>
             </a:r>
           </a:p>
           <a:p>
             <a:pPr lvl="2"/>
             <a:r>
-              <a:rPr lang="en-US" smtClean="0"/>
+              <a:rPr lang="en-US"/>
               <a:t>Third level</a:t>
             </a:r>
           </a:p>
           <a:p>
             <a:pPr lvl="3"/>
             <a:r>
-              <a:rPr lang="en-US" smtClean="0"/>
+              <a:rPr lang="en-US"/>
               <a:t>Fourth level</a:t>
             </a:r>
           </a:p>
           <a:p>
             <a:pPr lvl="4"/>
             <a:r>
-              <a:rPr lang="en-US" smtClean="0"/>
+              <a:rPr lang="en-US"/>
               <a:t>Fifth level</a:t>
             </a:r>
-            <a:endParaRPr lang="en-US"/>
           </a:p>
         </p:txBody>
       </p:sp>
@@ -814,7 +822,7 @@
           <a:p>
             <a:fld id="{5BCAD085-E8A6-8845-BD4E-CB4CCA059FC4}" type="datetimeFigureOut">
               <a:rPr lang="en-US" smtClean="0"/>
-              <a:t>1/27/13</a:t>
+              <a:t>7/10/2026</a:t>
             </a:fld>
             <a:endParaRPr lang="en-US"/>
           </a:p>
@@ -917,10 +925,9 @@
           </a:lstStyle>
           <a:p>
             <a:r>
-              <a:rPr lang="en-US" smtClean="0"/>
+              <a:rPr lang="en-US"/>
               <a:t>Click to edit Master title style</a:t>
             </a:r>
-            <a:endParaRPr lang="en-US"/>
           </a:p>
         </p:txBody>
       </p:sp>
@@ -1037,7 +1044,7 @@
           <a:p>
             <a:pPr lvl="0"/>
             <a:r>
-              <a:rPr lang="en-US" smtClean="0"/>
+              <a:rPr lang="en-US"/>
               <a:t>Click to edit Master text styles</a:t>
             </a:r>
           </a:p>
@@ -1060,7 +1067,7 @@
           <a:p>
             <a:fld id="{5BCAD085-E8A6-8845-BD4E-CB4CCA059FC4}" type="datetimeFigureOut">
               <a:rPr lang="en-US" smtClean="0"/>
-              <a:t>1/27/13</a:t>
+              <a:t>7/10/2026</a:t>
             </a:fld>
             <a:endParaRPr lang="en-US"/>
           </a:p>
@@ -1154,10 +1161,9 @@
           <a:lstStyle/>
           <a:p>
             <a:r>
-              <a:rPr lang="en-US" smtClean="0"/>
+              <a:rPr lang="en-US"/>
               <a:t>Click to edit Master title style</a:t>
             </a:r>
-            <a:endParaRPr lang="en-US"/>
           </a:p>
         </p:txBody>
       </p:sp>
@@ -1211,38 +1217,37 @@
           <a:p>
             <a:pPr lvl="0"/>
             <a:r>
-              <a:rPr lang="en-US" smtClean="0"/>
+              <a:rPr lang="en-US"/>
               <a:t>Click to edit Master text styles</a:t>
             </a:r>
           </a:p>
           <a:p>
             <a:pPr lvl="1"/>
             <a:r>
-              <a:rPr lang="en-US" smtClean="0"/>
+              <a:rPr lang="en-US"/>
               <a:t>Second level</a:t>
             </a:r>
           </a:p>
           <a:p>
             <a:pPr lvl="2"/>
             <a:r>
-              <a:rPr lang="en-US" smtClean="0"/>
+              <a:rPr lang="en-US"/>
               <a:t>Third level</a:t>
             </a:r>
           </a:p>
           <a:p>
             <a:pPr lvl="3"/>
             <a:r>
-              <a:rPr lang="en-US" smtClean="0"/>
+              <a:rPr lang="en-US"/>
               <a:t>Fourth level</a:t>
             </a:r>
           </a:p>
           <a:p>
             <a:pPr lvl="4"/>
             <a:r>
-              <a:rPr lang="en-US" smtClean="0"/>
+              <a:rPr lang="en-US"/>
               <a:t>Fifth level</a:t>
             </a:r>
-            <a:endParaRPr lang="en-US"/>
           </a:p>
         </p:txBody>
       </p:sp>
@@ -1296,38 +1301,37 @@
           <a:p>
             <a:pPr lvl="0"/>
             <a:r>
-              <a:rPr lang="en-US" smtClean="0"/>
+              <a:rPr lang="en-US"/>
               <a:t>Click to edit Master text styles</a:t>
             </a:r>
           </a:p>
           <a:p>
             <a:pPr lvl="1"/>
             <a:r>
-              <a:rPr lang="en-US" smtClean="0"/>
+              <a:rPr lang="en-US"/>
               <a:t>Second level</a:t>
             </a:r>
           </a:p>
           <a:p>
             <a:pPr lvl="2"/>
             <a:r>
-              <a:rPr lang="en-US" smtClean="0"/>
+              <a:rPr lang="en-US"/>
               <a:t>Third level</a:t>
             </a:r>
           </a:p>
           <a:p>
             <a:pPr lvl="3"/>
             <a:r>
-              <a:rPr lang="en-US" smtClean="0"/>
+              <a:rPr lang="en-US"/>
               <a:t>Fourth level</a:t>
             </a:r>
           </a:p>
           <a:p>
             <a:pPr lvl="4"/>
             <a:r>
-              <a:rPr lang="en-US" smtClean="0"/>
+              <a:rPr lang="en-US"/>
               <a:t>Fifth level</a:t>
             </a:r>
-            <a:endParaRPr lang="en-US"/>
           </a:p>
         </p:txBody>
       </p:sp>
@@ -1348,7 +1352,7 @@
           <a:p>
             <a:fld id="{5BCAD085-E8A6-8845-BD4E-CB4CCA059FC4}" type="datetimeFigureOut">
               <a:rPr lang="en-US" smtClean="0"/>
-              <a:t>1/27/13</a:t>
+              <a:t>7/10/2026</a:t>
             </a:fld>
             <a:endParaRPr lang="en-US"/>
           </a:p>
@@ -1446,10 +1450,9 @@
           </a:lstStyle>
           <a:p>
             <a:r>
-              <a:rPr lang="en-US" smtClean="0"/>
+              <a:rPr lang="en-US"/>
               <a:t>Click to edit Master title style</a:t>
             </a:r>
-            <a:endParaRPr lang="en-US"/>
           </a:p>
         </p:txBody>
       </p:sp>
@@ -1512,7 +1515,7 @@
           <a:p>
             <a:pPr lvl="0"/>
             <a:r>
-              <a:rPr lang="en-US" smtClean="0"/>
+              <a:rPr lang="en-US"/>
               <a:t>Click to edit Master text styles</a:t>
             </a:r>
           </a:p>
@@ -1568,38 +1571,37 @@
           <a:p>
             <a:pPr lvl="0"/>
             <a:r>
-              <a:rPr lang="en-US" smtClean="0"/>
+              <a:rPr lang="en-US"/>
               <a:t>Click to edit Master text styles</a:t>
             </a:r>
           </a:p>
           <a:p>
             <a:pPr lvl="1"/>
             <a:r>
-              <a:rPr lang="en-US" smtClean="0"/>
+              <a:rPr lang="en-US"/>
               <a:t>Second level</a:t>
             </a:r>
           </a:p>
           <a:p>
             <a:pPr lvl="2"/>
             <a:r>
-              <a:rPr lang="en-US" smtClean="0"/>
+              <a:rPr lang="en-US"/>
               <a:t>Third level</a:t>
             </a:r>
           </a:p>
           <a:p>
             <a:pPr lvl="3"/>
             <a:r>
-              <a:rPr lang="en-US" smtClean="0"/>
+              <a:rPr lang="en-US"/>
               <a:t>Fourth level</a:t>
             </a:r>
           </a:p>
           <a:p>
             <a:pPr lvl="4"/>
             <a:r>
-              <a:rPr lang="en-US" smtClean="0"/>
+              <a:rPr lang="en-US"/>
               <a:t>Fifth level</a:t>
             </a:r>
-            <a:endParaRPr lang="en-US"/>
           </a:p>
         </p:txBody>
       </p:sp>
@@ -1662,7 +1664,7 @@
           <a:p>
             <a:pPr lvl="0"/>
             <a:r>
-              <a:rPr lang="en-US" smtClean="0"/>
+              <a:rPr lang="en-US"/>
               <a:t>Click to edit Master text styles</a:t>
             </a:r>
           </a:p>
@@ -1718,38 +1720,37 @@
           <a:p>
             <a:pPr lvl="0"/>
             <a:r>
-              <a:rPr lang="en-US" smtClean="0"/>
+              <a:rPr lang="en-US"/>
               <a:t>Click to edit Master text styles</a:t>
             </a:r>
           </a:p>
           <a:p>
             <a:pPr lvl="1"/>
             <a:r>
-              <a:rPr lang="en-US" smtClean="0"/>
+              <a:rPr lang="en-US"/>
               <a:t>Second level</a:t>
             </a:r>
           </a:p>
           <a:p>
             <a:pPr lvl="2"/>
             <a:r>
-              <a:rPr lang="en-US" smtClean="0"/>
+              <a:rPr lang="en-US"/>
               <a:t>Third level</a:t>
             </a:r>
           </a:p>
           <a:p>
             <a:pPr lvl="3"/>
             <a:r>
-              <a:rPr lang="en-US" smtClean="0"/>
+              <a:rPr lang="en-US"/>
               <a:t>Fourth level</a:t>
             </a:r>
           </a:p>
           <a:p>
             <a:pPr lvl="4"/>
             <a:r>
-              <a:rPr lang="en-US" smtClean="0"/>
+              <a:rPr lang="en-US"/>
               <a:t>Fifth level</a:t>
             </a:r>
-            <a:endParaRPr lang="en-US"/>
           </a:p>
         </p:txBody>
       </p:sp>
@@ -1770,7 +1771,7 @@
           <a:p>
             <a:fld id="{5BCAD085-E8A6-8845-BD4E-CB4CCA059FC4}" type="datetimeFigureOut">
               <a:rPr lang="en-US" smtClean="0"/>
-              <a:t>1/27/13</a:t>
+              <a:t>7/10/2026</a:t>
             </a:fld>
             <a:endParaRPr lang="en-US"/>
           </a:p>
@@ -1864,10 +1865,9 @@
           <a:lstStyle/>
           <a:p>
             <a:r>
-              <a:rPr lang="en-US" smtClean="0"/>
+              <a:rPr lang="en-US"/>
               <a:t>Click to edit Master title style</a:t>
             </a:r>
-            <a:endParaRPr lang="en-US"/>
           </a:p>
         </p:txBody>
       </p:sp>
@@ -1888,7 +1888,7 @@
           <a:p>
             <a:fld id="{5BCAD085-E8A6-8845-BD4E-CB4CCA059FC4}" type="datetimeFigureOut">
               <a:rPr lang="en-US" smtClean="0"/>
-              <a:t>1/27/13</a:t>
+              <a:t>7/10/2026</a:t>
             </a:fld>
             <a:endParaRPr lang="en-US"/>
           </a:p>
@@ -1983,7 +1983,7 @@
           <a:p>
             <a:fld id="{5BCAD085-E8A6-8845-BD4E-CB4CCA059FC4}" type="datetimeFigureOut">
               <a:rPr lang="en-US" smtClean="0"/>
-              <a:t>1/27/13</a:t>
+              <a:t>7/10/2026</a:t>
             </a:fld>
             <a:endParaRPr lang="en-US"/>
           </a:p>
@@ -2086,10 +2086,9 @@
           </a:lstStyle>
           <a:p>
             <a:r>
-              <a:rPr lang="en-US" smtClean="0"/>
+              <a:rPr lang="en-US"/>
               <a:t>Click to edit Master title style</a:t>
             </a:r>
-            <a:endParaRPr lang="en-US"/>
           </a:p>
         </p:txBody>
       </p:sp>
@@ -2143,38 +2142,37 @@
           <a:p>
             <a:pPr lvl="0"/>
             <a:r>
-              <a:rPr lang="en-US" smtClean="0"/>
+              <a:rPr lang="en-US"/>
               <a:t>Click to edit Master text styles</a:t>
             </a:r>
           </a:p>
           <a:p>
             <a:pPr lvl="1"/>
             <a:r>
-              <a:rPr lang="en-US" smtClean="0"/>
+              <a:rPr lang="en-US"/>
               <a:t>Second level</a:t>
             </a:r>
           </a:p>
           <a:p>
             <a:pPr lvl="2"/>
             <a:r>
-              <a:rPr lang="en-US" smtClean="0"/>
+              <a:rPr lang="en-US"/>
               <a:t>Third level</a:t>
             </a:r>
           </a:p>
           <a:p>
             <a:pPr lvl="3"/>
             <a:r>
-              <a:rPr lang="en-US" smtClean="0"/>
+              <a:rPr lang="en-US"/>
               <a:t>Fourth level</a:t>
             </a:r>
           </a:p>
           <a:p>
             <a:pPr lvl="4"/>
             <a:r>
-              <a:rPr lang="en-US" smtClean="0"/>
+              <a:rPr lang="en-US"/>
               <a:t>Fifth level</a:t>
             </a:r>
-            <a:endParaRPr lang="en-US"/>
           </a:p>
         </p:txBody>
       </p:sp>
@@ -2237,7 +2235,7 @@
           <a:p>
             <a:pPr lvl="0"/>
             <a:r>
-              <a:rPr lang="en-US" smtClean="0"/>
+              <a:rPr lang="en-US"/>
               <a:t>Click to edit Master text styles</a:t>
             </a:r>
           </a:p>
@@ -2260,7 +2258,7 @@
           <a:p>
             <a:fld id="{5BCAD085-E8A6-8845-BD4E-CB4CCA059FC4}" type="datetimeFigureOut">
               <a:rPr lang="en-US" smtClean="0"/>
-              <a:t>1/27/13</a:t>
+              <a:t>7/10/2026</a:t>
             </a:fld>
             <a:endParaRPr lang="en-US"/>
           </a:p>
@@ -2363,10 +2361,9 @@
           </a:lstStyle>
           <a:p>
             <a:r>
-              <a:rPr lang="en-US" smtClean="0"/>
+              <a:rPr lang="en-US"/>
               <a:t>Click to edit Master title style</a:t>
             </a:r>
-            <a:endParaRPr lang="en-US"/>
           </a:p>
         </p:txBody>
       </p:sp>
@@ -2490,7 +2487,7 @@
           <a:p>
             <a:pPr lvl="0"/>
             <a:r>
-              <a:rPr lang="en-US" smtClean="0"/>
+              <a:rPr lang="en-US"/>
               <a:t>Click to edit Master text styles</a:t>
             </a:r>
           </a:p>
@@ -2513,7 +2510,7 @@
           <a:p>
             <a:fld id="{5BCAD085-E8A6-8845-BD4E-CB4CCA059FC4}" type="datetimeFigureOut">
               <a:rPr lang="en-US" smtClean="0"/>
-              <a:t>1/27/13</a:t>
+              <a:t>7/10/2026</a:t>
             </a:fld>
             <a:endParaRPr lang="en-US"/>
           </a:p>
@@ -2622,10 +2619,9 @@
           <a:lstStyle/>
           <a:p>
             <a:r>
-              <a:rPr lang="en-US" smtClean="0"/>
+              <a:rPr lang="en-US"/>
               <a:t>Click to edit Master title style</a:t>
             </a:r>
-            <a:endParaRPr lang="en-US"/>
           </a:p>
         </p:txBody>
       </p:sp>
@@ -2656,38 +2652,37 @@
           <a:p>
             <a:pPr lvl="0"/>
             <a:r>
-              <a:rPr lang="en-US" smtClean="0"/>
+              <a:rPr lang="en-US"/>
               <a:t>Click to edit Master text styles</a:t>
             </a:r>
           </a:p>
           <a:p>
             <a:pPr lvl="1"/>
             <a:r>
-              <a:rPr lang="en-US" smtClean="0"/>
+              <a:rPr lang="en-US"/>
               <a:t>Second level</a:t>
             </a:r>
           </a:p>
           <a:p>
             <a:pPr lvl="2"/>
             <a:r>
-              <a:rPr lang="en-US" smtClean="0"/>
+              <a:rPr lang="en-US"/>
               <a:t>Third level</a:t>
             </a:r>
           </a:p>
           <a:p>
             <a:pPr lvl="3"/>
             <a:r>
-              <a:rPr lang="en-US" smtClean="0"/>
+              <a:rPr lang="en-US"/>
               <a:t>Fourth level</a:t>
             </a:r>
           </a:p>
           <a:p>
             <a:pPr lvl="4"/>
             <a:r>
-              <a:rPr lang="en-US" smtClean="0"/>
+              <a:rPr lang="en-US"/>
               <a:t>Fifth level</a:t>
             </a:r>
-            <a:endParaRPr lang="en-US"/>
           </a:p>
         </p:txBody>
       </p:sp>
@@ -2726,7 +2721,7 @@
           <a:p>
             <a:fld id="{5BCAD085-E8A6-8845-BD4E-CB4CCA059FC4}" type="datetimeFigureOut">
               <a:rPr lang="en-US" smtClean="0"/>
-              <a:t>1/27/13</a:t>
+              <a:t>7/10/2026</a:t>
             </a:fld>
             <a:endParaRPr lang="en-US"/>
           </a:p>
@@ -3085,7 +3080,7 @@
 </file>
 
 <file path=ppt/slides/slide1.xml><?xml version="1.0" encoding="utf-8"?>
-<p:sld xmlns:a="http://schemas.openxmlformats.org/drawingml/2006/main" xmlns:p="http://schemas.openxmlformats.org/presentationml/2006/main" xmlns:r="http://schemas.openxmlformats.org/officeDocument/2006/relationships">
+<p:sld xmlns:a="http://schemas.openxmlformats.org/drawingml/2006/main" xmlns:r="http://schemas.openxmlformats.org/officeDocument/2006/relationships" xmlns:p="http://schemas.openxmlformats.org/presentationml/2006/main">
   <p:cSld>
     <p:spTree>
       <p:nvGrpSpPr>
@@ -3093,7 +3088,14 @@
         <p:cNvGrpSpPr/>
         <p:nvPr/>
       </p:nvGrpSpPr>
-      <p:grpSpPr/>
+      <p:grpSpPr>
+        <a:xfrm>
+          <a:off x="0" y="0"/>
+          <a:ext cx="0" cy="0"/>
+          <a:chOff x="0" y="0"/>
+          <a:chExt cx="0" cy="0"/>
+        </a:xfrm>
+      </p:grpSpPr>
       <p:pic>
         <p:nvPicPr>
           <p:cNvPr id="2" name="Picture 1" descr="Figure_1.png"/>
@@ -3171,7 +3173,7 @@
 </file>
 
 <file path=ppt/slides/slide2.xml><?xml version="1.0" encoding="utf-8"?>
-<p:sld xmlns:a="http://schemas.openxmlformats.org/drawingml/2006/main" xmlns:p="http://schemas.openxmlformats.org/presentationml/2006/main" xmlns:r="http://schemas.openxmlformats.org/officeDocument/2006/relationships">
+<p:sld xmlns:a="http://schemas.openxmlformats.org/drawingml/2006/main" xmlns:r="http://schemas.openxmlformats.org/officeDocument/2006/relationships" xmlns:p="http://schemas.openxmlformats.org/presentationml/2006/main">
   <p:cSld>
     <p:spTree>
       <p:nvGrpSpPr>
@@ -3179,7 +3181,14 @@
         <p:cNvGrpSpPr/>
         <p:nvPr/>
       </p:nvGrpSpPr>
-      <p:grpSpPr/>
+      <p:grpSpPr>
+        <a:xfrm>
+          <a:off x="0" y="0"/>
+          <a:ext cx="0" cy="0"/>
+          <a:chOff x="0" y="0"/>
+          <a:chExt cx="0" cy="0"/>
+        </a:xfrm>
+      </p:grpSpPr>
       <p:pic>
         <p:nvPicPr>
           <p:cNvPr id="2" name="Picture 1" descr="Figure_2.png"/>
@@ -3257,7 +3266,7 @@
 </file>
 
 <file path=ppt/slides/slide3.xml><?xml version="1.0" encoding="utf-8"?>
-<p:sld xmlns:a="http://schemas.openxmlformats.org/drawingml/2006/main" xmlns:p="http://schemas.openxmlformats.org/presentationml/2006/main" xmlns:r="http://schemas.openxmlformats.org/officeDocument/2006/relationships">
+<p:sld xmlns:a="http://schemas.openxmlformats.org/drawingml/2006/main" xmlns:r="http://schemas.openxmlformats.org/officeDocument/2006/relationships" xmlns:p="http://schemas.openxmlformats.org/presentationml/2006/main">
   <p:cSld>
     <p:spTree>
       <p:nvGrpSpPr>
@@ -3265,7 +3274,14 @@
         <p:cNvGrpSpPr/>
         <p:nvPr/>
       </p:nvGrpSpPr>
-      <p:grpSpPr/>
+      <p:grpSpPr>
+        <a:xfrm>
+          <a:off x="0" y="0"/>
+          <a:ext cx="0" cy="0"/>
+          <a:chOff x="0" y="0"/>
+          <a:chExt cx="0" cy="0"/>
+        </a:xfrm>
+      </p:grpSpPr>
       <p:pic>
         <p:nvPicPr>
           <p:cNvPr id="2" name="Picture 1" descr="Figure_3.png"/>
@@ -3343,7 +3359,7 @@
 </file>
 
 <file path=ppt/slides/slide4.xml><?xml version="1.0" encoding="utf-8"?>
-<p:sld xmlns:a="http://schemas.openxmlformats.org/drawingml/2006/main" xmlns:p="http://schemas.openxmlformats.org/presentationml/2006/main" xmlns:r="http://schemas.openxmlformats.org/officeDocument/2006/relationships">
+<p:sld xmlns:a="http://schemas.openxmlformats.org/drawingml/2006/main" xmlns:r="http://schemas.openxmlformats.org/officeDocument/2006/relationships" xmlns:p="http://schemas.openxmlformats.org/presentationml/2006/main">
   <p:cSld>
     <p:spTree>
       <p:nvGrpSpPr>
@@ -3351,7 +3367,14 @@
         <p:cNvGrpSpPr/>
         <p:nvPr/>
       </p:nvGrpSpPr>
-      <p:grpSpPr/>
+      <p:grpSpPr>
+        <a:xfrm>
+          <a:off x="0" y="0"/>
+          <a:ext cx="0" cy="0"/>
+          <a:chOff x="0" y="0"/>
+          <a:chExt cx="0" cy="0"/>
+        </a:xfrm>
+      </p:grpSpPr>
       <p:pic>
         <p:nvPicPr>
           <p:cNvPr id="2" name="Picture 1" descr="Figure_4.png"/>
@@ -3429,7 +3452,7 @@
 </file>
 
 <file path=ppt/slides/slide5.xml><?xml version="1.0" encoding="utf-8"?>
-<p:sld xmlns:a="http://schemas.openxmlformats.org/drawingml/2006/main" xmlns:p="http://schemas.openxmlformats.org/presentationml/2006/main" xmlns:r="http://schemas.openxmlformats.org/officeDocument/2006/relationships">
+<p:sld xmlns:a="http://schemas.openxmlformats.org/drawingml/2006/main" xmlns:r="http://schemas.openxmlformats.org/officeDocument/2006/relationships" xmlns:p="http://schemas.openxmlformats.org/presentationml/2006/main">
   <p:cSld>
     <p:spTree>
       <p:nvGrpSpPr>
@@ -3437,7 +3460,14 @@
         <p:cNvGrpSpPr/>
         <p:nvPr/>
       </p:nvGrpSpPr>
-      <p:grpSpPr/>
+      <p:grpSpPr>
+        <a:xfrm>
+          <a:off x="0" y="0"/>
+          <a:ext cx="0" cy="0"/>
+          <a:chOff x="0" y="0"/>
+          <a:chExt cx="0" cy="0"/>
+        </a:xfrm>
+      </p:grpSpPr>
       <p:pic>
         <p:nvPicPr>
           <p:cNvPr id="2" name="Picture 1" descr="Figure_5.png"/>
@@ -3515,7 +3545,7 @@
 </file>
 
 <file path=ppt/slides/slide6.xml><?xml version="1.0" encoding="utf-8"?>
-<p:sld xmlns:a="http://schemas.openxmlformats.org/drawingml/2006/main" xmlns:p="http://schemas.openxmlformats.org/presentationml/2006/main" xmlns:r="http://schemas.openxmlformats.org/officeDocument/2006/relationships">
+<p:sld xmlns:a="http://schemas.openxmlformats.org/drawingml/2006/main" xmlns:r="http://schemas.openxmlformats.org/officeDocument/2006/relationships" xmlns:p="http://schemas.openxmlformats.org/presentationml/2006/main">
   <p:cSld>
     <p:spTree>
       <p:nvGrpSpPr>
@@ -3523,7 +3553,14 @@
         <p:cNvGrpSpPr/>
         <p:nvPr/>
       </p:nvGrpSpPr>
-      <p:grpSpPr/>
+      <p:grpSpPr>
+        <a:xfrm>
+          <a:off x="0" y="0"/>
+          <a:ext cx="0" cy="0"/>
+          <a:chOff x="0" y="0"/>
+          <a:chExt cx="0" cy="0"/>
+        </a:xfrm>
+      </p:grpSpPr>
       <p:pic>
         <p:nvPicPr>
           <p:cNvPr id="2" name="Picture 1" descr="Figure_6.png"/>
@@ -3601,7 +3638,7 @@
 </file>
 
 <file path=ppt/slides/slide7.xml><?xml version="1.0" encoding="utf-8"?>
-<p:sld xmlns:a="http://schemas.openxmlformats.org/drawingml/2006/main" xmlns:p="http://schemas.openxmlformats.org/presentationml/2006/main" xmlns:r="http://schemas.openxmlformats.org/officeDocument/2006/relationships">
+<p:sld xmlns:a="http://schemas.openxmlformats.org/drawingml/2006/main" xmlns:r="http://schemas.openxmlformats.org/officeDocument/2006/relationships" xmlns:p="http://schemas.openxmlformats.org/presentationml/2006/main">
   <p:cSld>
     <p:spTree>
       <p:nvGrpSpPr>
@@ -3609,17 +3646,80 @@
         <p:cNvGrpSpPr/>
         <p:nvPr/>
       </p:nvGrpSpPr>
-      <p:grpSpPr/>
+      <p:grpSpPr>
+        <a:xfrm>
+          <a:off x="0" y="0"/>
+          <a:ext cx="0" cy="0"/>
+          <a:chOff x="0" y="0"/>
+          <a:chExt cx="0" cy="0"/>
+        </a:xfrm>
+      </p:grpSpPr>
+      <p:sp>
+        <p:nvSpPr>
+          <p:cNvPr id="3" name="TextBox 2"/>
+          <p:cNvSpPr txBox="1"/>
+          <p:nvPr/>
+        </p:nvSpPr>
+        <p:spPr>
+          <a:xfrm>
+            <a:off x="457200" y="6199632"/>
+            <a:ext cx="11277295" cy="457200"/>
+          </a:xfrm>
+          <a:prstGeom prst="rect">
+            <a:avLst/>
+          </a:prstGeom>
+          <a:noFill/>
+        </p:spPr>
+        <p:txBody>
+          <a:bodyPr wrap="none">
+            <a:spAutoFit/>
+          </a:bodyPr>
+          <a:lstStyle/>
+          <a:p>
+            <a:pPr algn="ctr"/>
+            <a:r>
+              <a:rPr sz="1100" b="1">
+                <a:solidFill>
+                  <a:srgbClr val="2B3E52"/>
+                </a:solidFill>
+                <a:latin typeface="Arial"/>
+              </a:rPr>
+              <a:t>Figure 7.  </a:t>
+            </a:r>
+            <a:r>
+              <a:rPr sz="1100">
+                <a:solidFill>
+                  <a:srgbClr val="7B838C"/>
+                </a:solidFill>
+                <a:latin typeface="Arial"/>
+              </a:rPr>
+              <a:t>Expert evaluation of the BCHAIN-ACCESS prototype</a:t>
+            </a:r>
+          </a:p>
+        </p:txBody>
+      </p:sp>
       <p:pic>
         <p:nvPicPr>
-          <p:cNvPr id="2" name="Picture 1" descr="Figure_7.png"/>
+          <p:cNvPr id="5" name="Picture 1">
+            <a:extLst>
+              <a:ext uri="{FF2B5EF4-FFF2-40B4-BE49-F238E27FC236}">
+                <a16:creationId xmlns:a16="http://schemas.microsoft.com/office/drawing/2014/main" id="{9D5BCAB7-1199-0AAA-6882-6DA94EA0AAE1}"/>
+              </a:ext>
+            </a:extLst>
+          </p:cNvPr>
           <p:cNvPicPr>
-            <a:picLocks noChangeAspect="1"/>
+            <a:picLocks/>
           </p:cNvPicPr>
           <p:nvPr/>
         </p:nvPicPr>
         <p:blipFill>
-          <a:blip r:embed="rId2"/>
+          <a:blip>
+            <a:extLst>
+              <a:ext uri="{96DAC541-7B7A-43D3-8B79-37D633B846F1}">
+                <asvg:svgBlip xmlns:asvg="http://schemas.microsoft.com/office/drawing/2016/SVG/main" r:embed="rId2"/>
+              </a:ext>
+            </a:extLst>
+          </a:blip>
           <a:stretch>
             <a:fillRect/>
           </a:stretch>
@@ -3634,50 +3734,6 @@
           </a:prstGeom>
         </p:spPr>
       </p:pic>
-      <p:sp>
-        <p:nvSpPr>
-          <p:cNvPr id="3" name="TextBox 2"/>
-          <p:cNvSpPr txBox="1"/>
-          <p:nvPr/>
-        </p:nvSpPr>
-        <p:spPr>
-          <a:xfrm>
-            <a:off x="457200" y="6199632"/>
-            <a:ext cx="11277295" cy="457200"/>
-          </a:xfrm>
-          <a:prstGeom prst="rect">
-            <a:avLst/>
-          </a:prstGeom>
-          <a:noFill/>
-        </p:spPr>
-        <p:txBody>
-          <a:bodyPr wrap="none">
-            <a:spAutoFit/>
-          </a:bodyPr>
-          <a:lstStyle/>
-          <a:p>
-            <a:pPr algn="ctr"/>
-            <a:r>
-              <a:rPr sz="1100" b="1">
-                <a:solidFill>
-                  <a:srgbClr val="2B3E52"/>
-                </a:solidFill>
-                <a:latin typeface="Arial"/>
-              </a:rPr>
-              <a:t>Figure 7.  </a:t>
-            </a:r>
-            <a:r>
-              <a:rPr sz="1100">
-                <a:solidFill>
-                  <a:srgbClr val="7B838C"/>
-                </a:solidFill>
-                <a:latin typeface="Arial"/>
-              </a:rPr>
-              <a:t>Expert evaluation of the BCHAIN-ACCESS prototype</a:t>
-            </a:r>
-          </a:p>
-        </p:txBody>
-      </p:sp>
     </p:spTree>
   </p:cSld>
   <p:clrMapOvr>

</xml_diff>

<commit_message>
Update paper limitations, supplementary gas/Slither tables, and compiled PDF assets from user-modified Figure 7 PPTX
</commit_message>
<xml_diff>
--- a/BCHAIN-ACCESS_Package/BCHAIN-ACCESS_All_Figures.pptx
+++ b/BCHAIN-ACCESS_Package/BCHAIN-ACCESS_All_Figures.pptx
@@ -3700,10 +3700,10 @@
       </p:sp>
       <p:pic>
         <p:nvPicPr>
-          <p:cNvPr id="5" name="Picture 1">
+          <p:cNvPr id="4" name="Picture 1">
             <a:extLst>
               <a:ext uri="{FF2B5EF4-FFF2-40B4-BE49-F238E27FC236}">
-                <a16:creationId xmlns:a16="http://schemas.microsoft.com/office/drawing/2014/main" id="{9D5BCAB7-1199-0AAA-6882-6DA94EA0AAE1}"/>
+                <a16:creationId xmlns:a16="http://schemas.microsoft.com/office/drawing/2014/main" id="{3D8FAAAE-0ECA-DFDC-72B7-836ACDBA98D1}"/>
               </a:ext>
             </a:extLst>
           </p:cNvPr>
@@ -3713,13 +3713,7 @@
           <p:nvPr/>
         </p:nvPicPr>
         <p:blipFill>
-          <a:blip>
-            <a:extLst>
-              <a:ext uri="{96DAC541-7B7A-43D3-8B79-37D633B846F1}">
-                <asvg:svgBlip xmlns:asvg="http://schemas.microsoft.com/office/drawing/2016/SVG/main" r:embed="rId2"/>
-              </a:ext>
-            </a:extLst>
-          </a:blip>
+          <a:blip r:embed="rId2"/>
           <a:stretch>
             <a:fillRect/>
           </a:stretch>

</xml_diff>